<commit_message>
Reconcile Day 12 lab gate with the Day 11 personal lab
Day 12's 'connect to the lab' gate assumed a class-hosted Kali + <LAB_HOST> model.
Students now build their own lab as Day 11 homework (WSL2 + Podman: Metasploitable2
10.89.1.10, DVWA 10.89.1.20, Juice Shop 10.89.1.30), so the gate becomes a verify
pass instead of a first-time connect. Path A = verify the own lab (lab.sh status,
sudo nmap -sn, nmap -sV); Path B = the old shared-Kali/VPN flow, kept as the
fallback for stragglers and Mac/ARM laptops that can't run WSL2. 'Take a VM
snapshot' replaced with 'know your podman rm -f + rebuild' since containers reset
differently than a VM. Updated the deck, teacher-notes, lab-connect-checklist, and
roe-template; rebuilt day12.html/.pptx.

Co-Authored-By: Claude Sonnet 5 <noreply@anthropic.com>
</commit_message>
<xml_diff>
--- a/lessons-v2/day12/day12.pptx
+++ b/lessons-v2/day12/day12.pptx
@@ -531,8 +531,9 @@
 ANALOGY (kitchen): a pentester = a hired health inspector with WRITTEN permission to try to
 break in, who then reports exactly how — with photos and fixes. Not a burglar. The one
 difference between them is a signed piece of paper.
-LAB: this is the GATE. Every student must reach the lab targets and snapshot today. Stragglers
-go on the shared Kali; fix their own VM after.</a:t>
+LAB: this is the GATE, but most students already built their lab as Day 11 homework — today
+is mostly VERIFY, not build. Anyone who didn't finish, or is on a Mac/ARM laptop, goes on the
+shared Kali; fix their own lab in office hours.</a:t>
             </a:r>
             <a:endParaRPr lang="en-US" dirty="0"/>
           </a:p>
@@ -711,10 +712,13 @@
           <a:p>
             <a:r>
               <a:rPr lang="en-US" dirty="0"/>
-              <a:t>18 min — THE GATE. Everyone must finish this. Checklist in assets/lab-connect-checklist.md.
-Stragglers: put them on the shared Kali for today, sort their own VM in office hours.
-Nobody starts Day 13 without lab access.
-If ICMP is blocked, `curl -I http://&lt;LAB_HOST&gt;:8080` or the scanner is the reachability test.</a:t>
+              <a:t>18 min — THE GATE, but lighter than it looks: most students already have a working lab from
+Day 11 homework, so this is a VERIFY pass (5-8 min), not a first connect. Spend the saved time
+on stragglers: shared-Kali onboarding for anyone who didn't finish Day 11 or can't run WSL2.
+Containers don't 'snapshot' like a VM - point 5 in the checklist is the reset instead: the
+targets are disposable, `podman rm -f &lt;name&gt;` + the one build command from Day 11's guide
+gets back to clean in under a minute. Say that explicitly so nobody hunts for a snapshot button.
+Nobody starts Day 13 without lab access.</a:t>
             </a:r>
             <a:endParaRPr lang="en-US" dirty="0"/>
           </a:p>

</xml_diff>